<commit_message>
docs: reconcile hackathon demo packet
</commit_message>
<xml_diff>
--- a/deliverables/slides/cortex-hackathon-demo.pptx
+++ b/deliverables/slides/cortex-hackathon-demo.pptx
@@ -892,7 +892,7 @@
                   <a:srgbClr val="EAF2FF"/>
                 </a:solidFill>
               </a:rPr>
-              <a:t>From source shape to evidence</a:t>
+              <a:t>MCP-first, control-plane companion</a:t>
             </a:r>
             <a:endParaRPr lang="en-US"/>
           </a:p>
@@ -927,7 +927,7 @@
                   <a:srgbClr val="C6D5EC"/>
                 </a:solidFill>
               </a:rPr>
-              <a:t>Provider-shaped fixtures → normalization → context chunks → retrieval → inspectable answer</a:t>
+              <a:t>Codex, Claude, and Cursor use Cortex through an MCP boundary; a local UI helps inspect evidence and health.</a:t>
             </a:r>
             <a:endParaRPr lang="en-US"/>
           </a:p>
@@ -962,7 +962,7 @@
                   <a:srgbClr val="C6D5EC"/>
                 </a:solidFill>
               </a:rPr>
-              <a:t>Target architecture shown; no live provider API, OAuth, customer workspace, or production index.</a:t>
+              <a:t>Postgres is canonical. Hosted Qdrant is the intended durable vector-index target — not deployed or proven here.</a:t>
             </a:r>
             <a:endParaRPr lang="en-US"/>
           </a:p>

</xml_diff>

<commit_message>
feat: add bounded provider imports and durable runtime readiness
</commit_message>
<xml_diff>
--- a/deliverables/slides/cortex-hackathon-demo.pptx
+++ b/deliverables/slides/cortex-hackathon-demo.pptx
@@ -892,7 +892,7 @@
                   <a:srgbClr val="EAF2FF"/>
                 </a:solidFill>
               </a:rPr>
-              <a:t>From source shape to evidence</a:t>
+              <a:t>MCP-first, control-plane companion</a:t>
             </a:r>
             <a:endParaRPr lang="en-US"/>
           </a:p>
@@ -927,7 +927,7 @@
                   <a:srgbClr val="C6D5EC"/>
                 </a:solidFill>
               </a:rPr>
-              <a:t>Provider-shaped fixtures → normalization → context chunks → retrieval → inspectable answer</a:t>
+              <a:t>Codex, Claude, and Cursor use Cortex through an MCP boundary; a local UI helps inspect evidence and health.</a:t>
             </a:r>
             <a:endParaRPr lang="en-US"/>
           </a:p>
@@ -962,7 +962,7 @@
                   <a:srgbClr val="C6D5EC"/>
                 </a:solidFill>
               </a:rPr>
-              <a:t>Target architecture shown; no live provider API, OAuth, customer workspace, or production index.</a:t>
+              <a:t>Postgres is canonical. Hosted Qdrant is the intended durable vector-index target — not deployed or proven here.</a:t>
             </a:r>
             <a:endParaRPr lang="en-US"/>
           </a:p>

</xml_diff>